<commit_message>
Submission: live URLs baked into deck + README (vercel + render)
</commit_message>
<xml_diff>
--- a/SWARN-CONTROL.AI.pptx
+++ b/SWARN-CONTROL.AI.pptx
@@ -5,18 +5,18 @@
     <p:sldMasterId id="2147483648" r:id="rId1"/>
   </p:sldMasterIdLst>
   <p:sldIdLst>
-    <p:sldId id="256" r:id="rId7"/>
-    <p:sldId id="257" r:id="rId8"/>
-    <p:sldId id="258" r:id="rId9"/>
-    <p:sldId id="259" r:id="rId10"/>
-    <p:sldId id="260" r:id="rId11"/>
-    <p:sldId id="261" r:id="rId12"/>
-    <p:sldId id="262" r:id="rId13"/>
-    <p:sldId id="263" r:id="rId14"/>
-    <p:sldId id="264" r:id="rId15"/>
-    <p:sldId id="265" r:id="rId16"/>
+    <p:sldId id="256" r:id="rId2"/>
+    <p:sldId id="257" r:id="rId3"/>
+    <p:sldId id="258" r:id="rId4"/>
+    <p:sldId id="259" r:id="rId5"/>
+    <p:sldId id="260" r:id="rId6"/>
+    <p:sldId id="261" r:id="rId7"/>
+    <p:sldId id="262" r:id="rId8"/>
+    <p:sldId id="263" r:id="rId9"/>
+    <p:sldId id="264" r:id="rId10"/>
+    <p:sldId id="265" r:id="rId11"/>
   </p:sldIdLst>
-  <p:sldSz cx="12188952" cy="6858000" type="screen4x3"/>
+  <p:sldSz cx="12188825" cy="6858000"/>
   <p:notesSz cx="6858000" cy="9144000"/>
   <p:defaultTextStyle>
     <a:defPPr>
@@ -113,6 +113,22 @@
       </a:defRPr>
     </a:lvl9pPr>
   </p:defaultTextStyle>
+  <p:extLst>
+    <p:ext uri="{EFAFB233-063F-42B5-8137-9DF3F51BA10A}">
+      <p15:sldGuideLst xmlns:p15="http://schemas.microsoft.com/office/powerpoint/2012/main">
+        <p15:guide id="1" orient="horz" pos="2160">
+          <p15:clr>
+            <a:srgbClr val="A4A3A4"/>
+          </p15:clr>
+        </p15:guide>
+        <p15:guide id="2" pos="2880">
+          <p15:clr>
+            <a:srgbClr val="A4A3A4"/>
+          </p15:clr>
+        </p15:guide>
+      </p15:sldGuideLst>
+    </p:ext>
+  </p:extLst>
 </p:presentation>
 </file>
 
@@ -154,10 +170,9 @@
           <a:lstStyle/>
           <a:p>
             <a:r>
-              <a:rPr lang="en-US" smtClean="0"/>
+              <a:rPr lang="en-US"/>
               <a:t>Click to edit Master title style</a:t>
             </a:r>
-            <a:endParaRPr lang="en-US"/>
           </a:p>
         </p:txBody>
       </p:sp>
@@ -273,10 +288,9 @@
           </a:lstStyle>
           <a:p>
             <a:r>
-              <a:rPr lang="en-US" smtClean="0"/>
+              <a:rPr lang="en-US"/>
               <a:t>Click to edit Master subtitle style</a:t>
             </a:r>
-            <a:endParaRPr lang="en-US"/>
           </a:p>
         </p:txBody>
       </p:sp>
@@ -297,7 +311,7 @@
           <a:p>
             <a:fld id="{5BCAD085-E8A6-8845-BD4E-CB4CCA059FC4}" type="datetimeFigureOut">
               <a:rPr lang="en-US" smtClean="0"/>
-              <a:t>1/27/13</a:t>
+              <a:t>10/2/2026</a:t>
             </a:fld>
             <a:endParaRPr lang="en-US"/>
           </a:p>
@@ -391,10 +405,9 @@
           <a:lstStyle/>
           <a:p>
             <a:r>
-              <a:rPr lang="en-US" smtClean="0"/>
+              <a:rPr lang="en-US"/>
               <a:t>Click to edit Master title style</a:t>
             </a:r>
-            <a:endParaRPr lang="en-US"/>
           </a:p>
         </p:txBody>
       </p:sp>
@@ -415,38 +428,37 @@
           <a:p>
             <a:pPr lvl="0"/>
             <a:r>
-              <a:rPr lang="en-US" smtClean="0"/>
+              <a:rPr lang="en-US"/>
               <a:t>Click to edit Master text styles</a:t>
             </a:r>
           </a:p>
           <a:p>
             <a:pPr lvl="1"/>
             <a:r>
-              <a:rPr lang="en-US" smtClean="0"/>
+              <a:rPr lang="en-US"/>
               <a:t>Second level</a:t>
             </a:r>
           </a:p>
           <a:p>
             <a:pPr lvl="2"/>
             <a:r>
-              <a:rPr lang="en-US" smtClean="0"/>
+              <a:rPr lang="en-US"/>
               <a:t>Third level</a:t>
             </a:r>
           </a:p>
           <a:p>
             <a:pPr lvl="3"/>
             <a:r>
-              <a:rPr lang="en-US" smtClean="0"/>
+              <a:rPr lang="en-US"/>
               <a:t>Fourth level</a:t>
             </a:r>
           </a:p>
           <a:p>
             <a:pPr lvl="4"/>
             <a:r>
-              <a:rPr lang="en-US" smtClean="0"/>
+              <a:rPr lang="en-US"/>
               <a:t>Fifth level</a:t>
             </a:r>
-            <a:endParaRPr lang="en-US"/>
           </a:p>
         </p:txBody>
       </p:sp>
@@ -467,7 +479,7 @@
           <a:p>
             <a:fld id="{5BCAD085-E8A6-8845-BD4E-CB4CCA059FC4}" type="datetimeFigureOut">
               <a:rPr lang="en-US" smtClean="0"/>
-              <a:t>1/27/13</a:t>
+              <a:t>10/2/2026</a:t>
             </a:fld>
             <a:endParaRPr lang="en-US"/>
           </a:p>
@@ -566,10 +578,9 @@
           <a:lstStyle/>
           <a:p>
             <a:r>
-              <a:rPr lang="en-US" smtClean="0"/>
+              <a:rPr lang="en-US"/>
               <a:t>Click to edit Master title style</a:t>
             </a:r>
-            <a:endParaRPr lang="en-US"/>
           </a:p>
         </p:txBody>
       </p:sp>
@@ -595,38 +606,37 @@
           <a:p>
             <a:pPr lvl="0"/>
             <a:r>
-              <a:rPr lang="en-US" smtClean="0"/>
+              <a:rPr lang="en-US"/>
               <a:t>Click to edit Master text styles</a:t>
             </a:r>
           </a:p>
           <a:p>
             <a:pPr lvl="1"/>
             <a:r>
-              <a:rPr lang="en-US" smtClean="0"/>
+              <a:rPr lang="en-US"/>
               <a:t>Second level</a:t>
             </a:r>
           </a:p>
           <a:p>
             <a:pPr lvl="2"/>
             <a:r>
-              <a:rPr lang="en-US" smtClean="0"/>
+              <a:rPr lang="en-US"/>
               <a:t>Third level</a:t>
             </a:r>
           </a:p>
           <a:p>
             <a:pPr lvl="3"/>
             <a:r>
-              <a:rPr lang="en-US" smtClean="0"/>
+              <a:rPr lang="en-US"/>
               <a:t>Fourth level</a:t>
             </a:r>
           </a:p>
           <a:p>
             <a:pPr lvl="4"/>
             <a:r>
-              <a:rPr lang="en-US" smtClean="0"/>
+              <a:rPr lang="en-US"/>
               <a:t>Fifth level</a:t>
             </a:r>
-            <a:endParaRPr lang="en-US"/>
           </a:p>
         </p:txBody>
       </p:sp>
@@ -647,7 +657,7 @@
           <a:p>
             <a:fld id="{5BCAD085-E8A6-8845-BD4E-CB4CCA059FC4}" type="datetimeFigureOut">
               <a:rPr lang="en-US" smtClean="0"/>
-              <a:t>1/27/13</a:t>
+              <a:t>10/2/2026</a:t>
             </a:fld>
             <a:endParaRPr lang="en-US"/>
           </a:p>
@@ -741,10 +751,9 @@
           <a:lstStyle/>
           <a:p>
             <a:r>
-              <a:rPr lang="en-US" smtClean="0"/>
+              <a:rPr lang="en-US"/>
               <a:t>Click to edit Master title style</a:t>
             </a:r>
-            <a:endParaRPr lang="en-US"/>
           </a:p>
         </p:txBody>
       </p:sp>
@@ -765,38 +774,37 @@
           <a:p>
             <a:pPr lvl="0"/>
             <a:r>
-              <a:rPr lang="en-US" smtClean="0"/>
+              <a:rPr lang="en-US"/>
               <a:t>Click to edit Master text styles</a:t>
             </a:r>
           </a:p>
           <a:p>
             <a:pPr lvl="1"/>
             <a:r>
-              <a:rPr lang="en-US" smtClean="0"/>
+              <a:rPr lang="en-US"/>
               <a:t>Second level</a:t>
             </a:r>
           </a:p>
           <a:p>
             <a:pPr lvl="2"/>
             <a:r>
-              <a:rPr lang="en-US" smtClean="0"/>
+              <a:rPr lang="en-US"/>
               <a:t>Third level</a:t>
             </a:r>
           </a:p>
           <a:p>
             <a:pPr lvl="3"/>
             <a:r>
-              <a:rPr lang="en-US" smtClean="0"/>
+              <a:rPr lang="en-US"/>
               <a:t>Fourth level</a:t>
             </a:r>
           </a:p>
           <a:p>
             <a:pPr lvl="4"/>
             <a:r>
-              <a:rPr lang="en-US" smtClean="0"/>
+              <a:rPr lang="en-US"/>
               <a:t>Fifth level</a:t>
             </a:r>
-            <a:endParaRPr lang="en-US"/>
           </a:p>
         </p:txBody>
       </p:sp>
@@ -817,7 +825,7 @@
           <a:p>
             <a:fld id="{5BCAD085-E8A6-8845-BD4E-CB4CCA059FC4}" type="datetimeFigureOut">
               <a:rPr lang="en-US" smtClean="0"/>
-              <a:t>1/27/13</a:t>
+              <a:t>10/2/2026</a:t>
             </a:fld>
             <a:endParaRPr lang="en-US"/>
           </a:p>
@@ -920,10 +928,9 @@
           </a:lstStyle>
           <a:p>
             <a:r>
-              <a:rPr lang="en-US" smtClean="0"/>
+              <a:rPr lang="en-US"/>
               <a:t>Click to edit Master title style</a:t>
             </a:r>
-            <a:endParaRPr lang="en-US"/>
           </a:p>
         </p:txBody>
       </p:sp>
@@ -1040,7 +1047,7 @@
           <a:p>
             <a:pPr lvl="0"/>
             <a:r>
-              <a:rPr lang="en-US" smtClean="0"/>
+              <a:rPr lang="en-US"/>
               <a:t>Click to edit Master text styles</a:t>
             </a:r>
           </a:p>
@@ -1063,7 +1070,7 @@
           <a:p>
             <a:fld id="{5BCAD085-E8A6-8845-BD4E-CB4CCA059FC4}" type="datetimeFigureOut">
               <a:rPr lang="en-US" smtClean="0"/>
-              <a:t>1/27/13</a:t>
+              <a:t>10/2/2026</a:t>
             </a:fld>
             <a:endParaRPr lang="en-US"/>
           </a:p>
@@ -1157,10 +1164,9 @@
           <a:lstStyle/>
           <a:p>
             <a:r>
-              <a:rPr lang="en-US" smtClean="0"/>
+              <a:rPr lang="en-US"/>
               <a:t>Click to edit Master title style</a:t>
             </a:r>
-            <a:endParaRPr lang="en-US"/>
           </a:p>
         </p:txBody>
       </p:sp>
@@ -1214,38 +1220,37 @@
           <a:p>
             <a:pPr lvl="0"/>
             <a:r>
-              <a:rPr lang="en-US" smtClean="0"/>
+              <a:rPr lang="en-US"/>
               <a:t>Click to edit Master text styles</a:t>
             </a:r>
           </a:p>
           <a:p>
             <a:pPr lvl="1"/>
             <a:r>
-              <a:rPr lang="en-US" smtClean="0"/>
+              <a:rPr lang="en-US"/>
               <a:t>Second level</a:t>
             </a:r>
           </a:p>
           <a:p>
             <a:pPr lvl="2"/>
             <a:r>
-              <a:rPr lang="en-US" smtClean="0"/>
+              <a:rPr lang="en-US"/>
               <a:t>Third level</a:t>
             </a:r>
           </a:p>
           <a:p>
             <a:pPr lvl="3"/>
             <a:r>
-              <a:rPr lang="en-US" smtClean="0"/>
+              <a:rPr lang="en-US"/>
               <a:t>Fourth level</a:t>
             </a:r>
           </a:p>
           <a:p>
             <a:pPr lvl="4"/>
             <a:r>
-              <a:rPr lang="en-US" smtClean="0"/>
+              <a:rPr lang="en-US"/>
               <a:t>Fifth level</a:t>
             </a:r>
-            <a:endParaRPr lang="en-US"/>
           </a:p>
         </p:txBody>
       </p:sp>
@@ -1299,38 +1304,37 @@
           <a:p>
             <a:pPr lvl="0"/>
             <a:r>
-              <a:rPr lang="en-US" smtClean="0"/>
+              <a:rPr lang="en-US"/>
               <a:t>Click to edit Master text styles</a:t>
             </a:r>
           </a:p>
           <a:p>
             <a:pPr lvl="1"/>
             <a:r>
-              <a:rPr lang="en-US" smtClean="0"/>
+              <a:rPr lang="en-US"/>
               <a:t>Second level</a:t>
             </a:r>
           </a:p>
           <a:p>
             <a:pPr lvl="2"/>
             <a:r>
-              <a:rPr lang="en-US" smtClean="0"/>
+              <a:rPr lang="en-US"/>
               <a:t>Third level</a:t>
             </a:r>
           </a:p>
           <a:p>
             <a:pPr lvl="3"/>
             <a:r>
-              <a:rPr lang="en-US" smtClean="0"/>
+              <a:rPr lang="en-US"/>
               <a:t>Fourth level</a:t>
             </a:r>
           </a:p>
           <a:p>
             <a:pPr lvl="4"/>
             <a:r>
-              <a:rPr lang="en-US" smtClean="0"/>
+              <a:rPr lang="en-US"/>
               <a:t>Fifth level</a:t>
             </a:r>
-            <a:endParaRPr lang="en-US"/>
           </a:p>
         </p:txBody>
       </p:sp>
@@ -1351,7 +1355,7 @@
           <a:p>
             <a:fld id="{5BCAD085-E8A6-8845-BD4E-CB4CCA059FC4}" type="datetimeFigureOut">
               <a:rPr lang="en-US" smtClean="0"/>
-              <a:t>1/27/13</a:t>
+              <a:t>10/2/2026</a:t>
             </a:fld>
             <a:endParaRPr lang="en-US"/>
           </a:p>
@@ -1449,10 +1453,9 @@
           </a:lstStyle>
           <a:p>
             <a:r>
-              <a:rPr lang="en-US" smtClean="0"/>
+              <a:rPr lang="en-US"/>
               <a:t>Click to edit Master title style</a:t>
             </a:r>
-            <a:endParaRPr lang="en-US"/>
           </a:p>
         </p:txBody>
       </p:sp>
@@ -1515,7 +1518,7 @@
           <a:p>
             <a:pPr lvl="0"/>
             <a:r>
-              <a:rPr lang="en-US" smtClean="0"/>
+              <a:rPr lang="en-US"/>
               <a:t>Click to edit Master text styles</a:t>
             </a:r>
           </a:p>
@@ -1571,38 +1574,37 @@
           <a:p>
             <a:pPr lvl="0"/>
             <a:r>
-              <a:rPr lang="en-US" smtClean="0"/>
+              <a:rPr lang="en-US"/>
               <a:t>Click to edit Master text styles</a:t>
             </a:r>
           </a:p>
           <a:p>
             <a:pPr lvl="1"/>
             <a:r>
-              <a:rPr lang="en-US" smtClean="0"/>
+              <a:rPr lang="en-US"/>
               <a:t>Second level</a:t>
             </a:r>
           </a:p>
           <a:p>
             <a:pPr lvl="2"/>
             <a:r>
-              <a:rPr lang="en-US" smtClean="0"/>
+              <a:rPr lang="en-US"/>
               <a:t>Third level</a:t>
             </a:r>
           </a:p>
           <a:p>
             <a:pPr lvl="3"/>
             <a:r>
-              <a:rPr lang="en-US" smtClean="0"/>
+              <a:rPr lang="en-US"/>
               <a:t>Fourth level</a:t>
             </a:r>
           </a:p>
           <a:p>
             <a:pPr lvl="4"/>
             <a:r>
-              <a:rPr lang="en-US" smtClean="0"/>
+              <a:rPr lang="en-US"/>
               <a:t>Fifth level</a:t>
             </a:r>
-            <a:endParaRPr lang="en-US"/>
           </a:p>
         </p:txBody>
       </p:sp>
@@ -1665,7 +1667,7 @@
           <a:p>
             <a:pPr lvl="0"/>
             <a:r>
-              <a:rPr lang="en-US" smtClean="0"/>
+              <a:rPr lang="en-US"/>
               <a:t>Click to edit Master text styles</a:t>
             </a:r>
           </a:p>
@@ -1721,38 +1723,37 @@
           <a:p>
             <a:pPr lvl="0"/>
             <a:r>
-              <a:rPr lang="en-US" smtClean="0"/>
+              <a:rPr lang="en-US"/>
               <a:t>Click to edit Master text styles</a:t>
             </a:r>
           </a:p>
           <a:p>
             <a:pPr lvl="1"/>
             <a:r>
-              <a:rPr lang="en-US" smtClean="0"/>
+              <a:rPr lang="en-US"/>
               <a:t>Second level</a:t>
             </a:r>
           </a:p>
           <a:p>
             <a:pPr lvl="2"/>
             <a:r>
-              <a:rPr lang="en-US" smtClean="0"/>
+              <a:rPr lang="en-US"/>
               <a:t>Third level</a:t>
             </a:r>
           </a:p>
           <a:p>
             <a:pPr lvl="3"/>
             <a:r>
-              <a:rPr lang="en-US" smtClean="0"/>
+              <a:rPr lang="en-US"/>
               <a:t>Fourth level</a:t>
             </a:r>
           </a:p>
           <a:p>
             <a:pPr lvl="4"/>
             <a:r>
-              <a:rPr lang="en-US" smtClean="0"/>
+              <a:rPr lang="en-US"/>
               <a:t>Fifth level</a:t>
             </a:r>
-            <a:endParaRPr lang="en-US"/>
           </a:p>
         </p:txBody>
       </p:sp>
@@ -1773,7 +1774,7 @@
           <a:p>
             <a:fld id="{5BCAD085-E8A6-8845-BD4E-CB4CCA059FC4}" type="datetimeFigureOut">
               <a:rPr lang="en-US" smtClean="0"/>
-              <a:t>1/27/13</a:t>
+              <a:t>10/2/2026</a:t>
             </a:fld>
             <a:endParaRPr lang="en-US"/>
           </a:p>
@@ -1867,10 +1868,9 @@
           <a:lstStyle/>
           <a:p>
             <a:r>
-              <a:rPr lang="en-US" smtClean="0"/>
+              <a:rPr lang="en-US"/>
               <a:t>Click to edit Master title style</a:t>
             </a:r>
-            <a:endParaRPr lang="en-US"/>
           </a:p>
         </p:txBody>
       </p:sp>
@@ -1891,7 +1891,7 @@
           <a:p>
             <a:fld id="{5BCAD085-E8A6-8845-BD4E-CB4CCA059FC4}" type="datetimeFigureOut">
               <a:rPr lang="en-US" smtClean="0"/>
-              <a:t>1/27/13</a:t>
+              <a:t>10/2/2026</a:t>
             </a:fld>
             <a:endParaRPr lang="en-US"/>
           </a:p>
@@ -1986,7 +1986,7 @@
           <a:p>
             <a:fld id="{5BCAD085-E8A6-8845-BD4E-CB4CCA059FC4}" type="datetimeFigureOut">
               <a:rPr lang="en-US" smtClean="0"/>
-              <a:t>1/27/13</a:t>
+              <a:t>10/2/2026</a:t>
             </a:fld>
             <a:endParaRPr lang="en-US"/>
           </a:p>
@@ -2089,10 +2089,9 @@
           </a:lstStyle>
           <a:p>
             <a:r>
-              <a:rPr lang="en-US" smtClean="0"/>
+              <a:rPr lang="en-US"/>
               <a:t>Click to edit Master title style</a:t>
             </a:r>
-            <a:endParaRPr lang="en-US"/>
           </a:p>
         </p:txBody>
       </p:sp>
@@ -2146,38 +2145,37 @@
           <a:p>
             <a:pPr lvl="0"/>
             <a:r>
-              <a:rPr lang="en-US" smtClean="0"/>
+              <a:rPr lang="en-US"/>
               <a:t>Click to edit Master text styles</a:t>
             </a:r>
           </a:p>
           <a:p>
             <a:pPr lvl="1"/>
             <a:r>
-              <a:rPr lang="en-US" smtClean="0"/>
+              <a:rPr lang="en-US"/>
               <a:t>Second level</a:t>
             </a:r>
           </a:p>
           <a:p>
             <a:pPr lvl="2"/>
             <a:r>
-              <a:rPr lang="en-US" smtClean="0"/>
+              <a:rPr lang="en-US"/>
               <a:t>Third level</a:t>
             </a:r>
           </a:p>
           <a:p>
             <a:pPr lvl="3"/>
             <a:r>
-              <a:rPr lang="en-US" smtClean="0"/>
+              <a:rPr lang="en-US"/>
               <a:t>Fourth level</a:t>
             </a:r>
           </a:p>
           <a:p>
             <a:pPr lvl="4"/>
             <a:r>
-              <a:rPr lang="en-US" smtClean="0"/>
+              <a:rPr lang="en-US"/>
               <a:t>Fifth level</a:t>
             </a:r>
-            <a:endParaRPr lang="en-US"/>
           </a:p>
         </p:txBody>
       </p:sp>
@@ -2240,7 +2238,7 @@
           <a:p>
             <a:pPr lvl="0"/>
             <a:r>
-              <a:rPr lang="en-US" smtClean="0"/>
+              <a:rPr lang="en-US"/>
               <a:t>Click to edit Master text styles</a:t>
             </a:r>
           </a:p>
@@ -2263,7 +2261,7 @@
           <a:p>
             <a:fld id="{5BCAD085-E8A6-8845-BD4E-CB4CCA059FC4}" type="datetimeFigureOut">
               <a:rPr lang="en-US" smtClean="0"/>
-              <a:t>1/27/13</a:t>
+              <a:t>10/2/2026</a:t>
             </a:fld>
             <a:endParaRPr lang="en-US"/>
           </a:p>
@@ -2366,10 +2364,9 @@
           </a:lstStyle>
           <a:p>
             <a:r>
-              <a:rPr lang="en-US" smtClean="0"/>
+              <a:rPr lang="en-US"/>
               <a:t>Click to edit Master title style</a:t>
             </a:r>
-            <a:endParaRPr lang="en-US"/>
           </a:p>
         </p:txBody>
       </p:sp>
@@ -2493,7 +2490,7 @@
           <a:p>
             <a:pPr lvl="0"/>
             <a:r>
-              <a:rPr lang="en-US" smtClean="0"/>
+              <a:rPr lang="en-US"/>
               <a:t>Click to edit Master text styles</a:t>
             </a:r>
           </a:p>
@@ -2516,7 +2513,7 @@
           <a:p>
             <a:fld id="{5BCAD085-E8A6-8845-BD4E-CB4CCA059FC4}" type="datetimeFigureOut">
               <a:rPr lang="en-US" smtClean="0"/>
-              <a:t>1/27/13</a:t>
+              <a:t>10/2/2026</a:t>
             </a:fld>
             <a:endParaRPr lang="en-US"/>
           </a:p>
@@ -2625,10 +2622,9 @@
           <a:lstStyle/>
           <a:p>
             <a:r>
-              <a:rPr lang="en-US" smtClean="0"/>
+              <a:rPr lang="en-US"/>
               <a:t>Click to edit Master title style</a:t>
             </a:r>
-            <a:endParaRPr lang="en-US"/>
           </a:p>
         </p:txBody>
       </p:sp>
@@ -2659,38 +2655,37 @@
           <a:p>
             <a:pPr lvl="0"/>
             <a:r>
-              <a:rPr lang="en-US" smtClean="0"/>
+              <a:rPr lang="en-US"/>
               <a:t>Click to edit Master text styles</a:t>
             </a:r>
           </a:p>
           <a:p>
             <a:pPr lvl="1"/>
             <a:r>
-              <a:rPr lang="en-US" smtClean="0"/>
+              <a:rPr lang="en-US"/>
               <a:t>Second level</a:t>
             </a:r>
           </a:p>
           <a:p>
             <a:pPr lvl="2"/>
             <a:r>
-              <a:rPr lang="en-US" smtClean="0"/>
+              <a:rPr lang="en-US"/>
               <a:t>Third level</a:t>
             </a:r>
           </a:p>
           <a:p>
             <a:pPr lvl="3"/>
             <a:r>
-              <a:rPr lang="en-US" smtClean="0"/>
+              <a:rPr lang="en-US"/>
               <a:t>Fourth level</a:t>
             </a:r>
           </a:p>
           <a:p>
             <a:pPr lvl="4"/>
             <a:r>
-              <a:rPr lang="en-US" smtClean="0"/>
+              <a:rPr lang="en-US"/>
               <a:t>Fifth level</a:t>
             </a:r>
-            <a:endParaRPr lang="en-US"/>
           </a:p>
         </p:txBody>
       </p:sp>
@@ -2729,7 +2724,7 @@
           <a:p>
             <a:fld id="{5BCAD085-E8A6-8845-BD4E-CB4CCA059FC4}" type="datetimeFigureOut">
               <a:rPr lang="en-US" smtClean="0"/>
-              <a:t>1/27/13</a:t>
+              <a:t>10/2/2026</a:t>
             </a:fld>
             <a:endParaRPr lang="en-US"/>
           </a:p>
@@ -3088,7 +3083,7 @@
 </file>
 
 <file path=ppt/slides/slide1.xml><?xml version="1.0" encoding="utf-8"?>
-<p:sld xmlns:a="http://schemas.openxmlformats.org/drawingml/2006/main" xmlns:p="http://schemas.openxmlformats.org/presentationml/2006/main" xmlns:r="http://schemas.openxmlformats.org/officeDocument/2006/relationships">
+<p:sld xmlns:a="http://schemas.openxmlformats.org/drawingml/2006/main" xmlns:r="http://schemas.openxmlformats.org/officeDocument/2006/relationships" xmlns:p="http://schemas.openxmlformats.org/presentationml/2006/main">
   <p:cSld>
     <p:bg>
       <p:bgPr>
@@ -3104,7 +3099,14 @@
         <p:cNvGrpSpPr/>
         <p:nvPr/>
       </p:nvGrpSpPr>
-      <p:grpSpPr/>
+      <p:grpSpPr>
+        <a:xfrm>
+          <a:off x="0" y="0"/>
+          <a:ext cx="0" cy="0"/>
+          <a:chOff x="0" y="0"/>
+          <a:chExt cx="0" cy="0"/>
+        </a:xfrm>
+      </p:grpSpPr>
       <p:sp>
         <p:nvSpPr>
           <p:cNvPr id="2" name="TextBox 1"/>
@@ -3318,7 +3320,7 @@
 </file>
 
 <file path=ppt/slides/slide10.xml><?xml version="1.0" encoding="utf-8"?>
-<p:sld xmlns:a="http://schemas.openxmlformats.org/drawingml/2006/main" xmlns:p="http://schemas.openxmlformats.org/presentationml/2006/main" xmlns:r="http://schemas.openxmlformats.org/officeDocument/2006/relationships">
+<p:sld xmlns:a="http://schemas.openxmlformats.org/drawingml/2006/main" xmlns:r="http://schemas.openxmlformats.org/officeDocument/2006/relationships" xmlns:p="http://schemas.openxmlformats.org/presentationml/2006/main">
   <p:cSld>
     <p:bg>
       <p:bgPr>
@@ -3334,7 +3336,14 @@
         <p:cNvGrpSpPr/>
         <p:nvPr/>
       </p:nvGrpSpPr>
-      <p:grpSpPr/>
+      <p:grpSpPr>
+        <a:xfrm>
+          <a:off x="0" y="0"/>
+          <a:ext cx="0" cy="0"/>
+          <a:chOff x="0" y="0"/>
+          <a:chExt cx="0" cy="0"/>
+        </a:xfrm>
+      </p:grpSpPr>
       <p:sp>
         <p:nvSpPr>
           <p:cNvPr id="2" name="TextBox 1"/>
@@ -3412,7 +3421,7 @@
         <p:spPr>
           <a:xfrm>
             <a:off x="731520" y="2194560"/>
-            <a:ext cx="10698480" cy="3840480"/>
+            <a:ext cx="10698480" cy="2395528"/>
           </a:xfrm>
           <a:prstGeom prst="rect">
             <a:avLst/>
@@ -3431,7 +3440,7 @@
               </a:spcAft>
             </a:pPr>
             <a:r>
-              <a:rPr sz="1800">
+              <a:rPr sz="1800" dirty="0">
                 <a:solidFill>
                   <a:srgbClr val="F2ECE2"/>
                 </a:solidFill>
@@ -3446,7 +3455,7 @@
               </a:spcAft>
             </a:pPr>
             <a:r>
-              <a:rPr sz="1800">
+              <a:rPr sz="1800" dirty="0">
                 <a:solidFill>
                   <a:srgbClr val="F2ECE2"/>
                 </a:solidFill>
@@ -3461,13 +3470,34 @@
               </a:spcAft>
             </a:pPr>
             <a:r>
-              <a:rPr sz="1800">
+              <a:rPr sz="1800" dirty="0">
                 <a:solidFill>
                   <a:srgbClr val="22D3EE"/>
                 </a:solidFill>
               </a:rPr>
-              <a:t>▸  Live Demo: &lt;vercel-url&gt;  ·  Backend: &lt;render-url&gt;  ·  GitHub: github.com/Aryansneha1845/SWARNA-CONTROL.AI</a:t>
-            </a:r>
+              <a:t>▸  Live Demo: </a:t>
+            </a:r>
+            <a:r>
+              <a:rPr lang="en-IN" dirty="0">
+                <a:solidFill>
+                  <a:srgbClr val="22D3EE"/>
+                </a:solidFill>
+              </a:rPr>
+              <a:t>https://swarna-control-ai.vercel.app</a:t>
+            </a:r>
+            <a:r>
+              <a:rPr sz="1800" dirty="0">
+                <a:solidFill>
+                  <a:srgbClr val="22D3EE"/>
+                </a:solidFill>
+              </a:rPr>
+              <a:t>· </a:t>
+            </a:r>
+            <a:endParaRPr lang="en-US" sz="1800" dirty="0">
+              <a:solidFill>
+                <a:srgbClr val="22D3EE"/>
+              </a:solidFill>
+            </a:endParaRPr>
           </a:p>
           <a:p>
             <a:pPr>
@@ -3476,7 +3506,58 @@
               </a:spcAft>
             </a:pPr>
             <a:r>
-              <a:rPr sz="1800">
+              <a:rPr sz="1800" dirty="0">
+                <a:solidFill>
+                  <a:srgbClr val="22D3EE"/>
+                </a:solidFill>
+              </a:rPr>
+              <a:t> Backend: </a:t>
+            </a:r>
+            <a:r>
+              <a:rPr lang="en-IN" dirty="0">
+                <a:solidFill>
+                  <a:srgbClr val="22D3EE"/>
+                </a:solidFill>
+              </a:rPr>
+              <a:t> https://swarn-control-backend.onrender.com</a:t>
+            </a:r>
+            <a:r>
+              <a:rPr sz="1800" dirty="0">
+                <a:solidFill>
+                  <a:srgbClr val="22D3EE"/>
+                </a:solidFill>
+              </a:rPr>
+              <a:t>· </a:t>
+            </a:r>
+            <a:endParaRPr lang="en-US" sz="1800" dirty="0">
+              <a:solidFill>
+                <a:srgbClr val="22D3EE"/>
+              </a:solidFill>
+            </a:endParaRPr>
+          </a:p>
+          <a:p>
+            <a:pPr>
+              <a:spcAft>
+                <a:spcPts val="1000"/>
+              </a:spcAft>
+            </a:pPr>
+            <a:r>
+              <a:rPr sz="1800" dirty="0">
+                <a:solidFill>
+                  <a:srgbClr val="22D3EE"/>
+                </a:solidFill>
+              </a:rPr>
+              <a:t> GitHub: github.com/Aryansneha1845/SWARNA-CONTROL.AI</a:t>
+            </a:r>
+          </a:p>
+          <a:p>
+            <a:pPr>
+              <a:spcAft>
+                <a:spcPts val="1000"/>
+              </a:spcAft>
+            </a:pPr>
+            <a:r>
+              <a:rPr sz="1800" dirty="0">
                 <a:solidFill>
                   <a:srgbClr val="93A1B5"/>
                 </a:solidFill>
@@ -3510,7 +3591,7 @@
           <a:p>
             <a:pPr algn="l"/>
             <a:r>
-              <a:rPr sz="1300" b="0">
+              <a:rPr sz="1300" b="0" dirty="0">
                 <a:solidFill>
                   <a:srgbClr val="93A1B5"/>
                 </a:solidFill>
@@ -3529,7 +3610,7 @@
 </file>
 
 <file path=ppt/slides/slide2.xml><?xml version="1.0" encoding="utf-8"?>
-<p:sld xmlns:a="http://schemas.openxmlformats.org/drawingml/2006/main" xmlns:p="http://schemas.openxmlformats.org/presentationml/2006/main" xmlns:r="http://schemas.openxmlformats.org/officeDocument/2006/relationships">
+<p:sld xmlns:a="http://schemas.openxmlformats.org/drawingml/2006/main" xmlns:r="http://schemas.openxmlformats.org/officeDocument/2006/relationships" xmlns:p="http://schemas.openxmlformats.org/presentationml/2006/main">
   <p:cSld>
     <p:bg>
       <p:bgPr>
@@ -3545,7 +3626,14 @@
         <p:cNvGrpSpPr/>
         <p:nvPr/>
       </p:nvGrpSpPr>
-      <p:grpSpPr/>
+      <p:grpSpPr>
+        <a:xfrm>
+          <a:off x="0" y="0"/>
+          <a:ext cx="0" cy="0"/>
+          <a:chOff x="0" y="0"/>
+          <a:chExt cx="0" cy="0"/>
+        </a:xfrm>
+      </p:grpSpPr>
       <p:sp>
         <p:nvSpPr>
           <p:cNvPr id="2" name="TextBox 1"/>
@@ -3706,7 +3794,7 @@
 </file>
 
 <file path=ppt/slides/slide3.xml><?xml version="1.0" encoding="utf-8"?>
-<p:sld xmlns:a="http://schemas.openxmlformats.org/drawingml/2006/main" xmlns:p="http://schemas.openxmlformats.org/presentationml/2006/main" xmlns:r="http://schemas.openxmlformats.org/officeDocument/2006/relationships">
+<p:sld xmlns:a="http://schemas.openxmlformats.org/drawingml/2006/main" xmlns:r="http://schemas.openxmlformats.org/officeDocument/2006/relationships" xmlns:p="http://schemas.openxmlformats.org/presentationml/2006/main">
   <p:cSld>
     <p:bg>
       <p:bgPr>
@@ -3722,7 +3810,14 @@
         <p:cNvGrpSpPr/>
         <p:nvPr/>
       </p:nvGrpSpPr>
-      <p:grpSpPr/>
+      <p:grpSpPr>
+        <a:xfrm>
+          <a:off x="0" y="0"/>
+          <a:ext cx="0" cy="0"/>
+          <a:chOff x="0" y="0"/>
+          <a:chExt cx="0" cy="0"/>
+        </a:xfrm>
+      </p:grpSpPr>
       <p:sp>
         <p:nvSpPr>
           <p:cNvPr id="2" name="TextBox 1"/>
@@ -3917,7 +4012,7 @@
 </file>
 
 <file path=ppt/slides/slide4.xml><?xml version="1.0" encoding="utf-8"?>
-<p:sld xmlns:a="http://schemas.openxmlformats.org/drawingml/2006/main" xmlns:p="http://schemas.openxmlformats.org/presentationml/2006/main" xmlns:r="http://schemas.openxmlformats.org/officeDocument/2006/relationships">
+<p:sld xmlns:a="http://schemas.openxmlformats.org/drawingml/2006/main" xmlns:r="http://schemas.openxmlformats.org/officeDocument/2006/relationships" xmlns:p="http://schemas.openxmlformats.org/presentationml/2006/main">
   <p:cSld>
     <p:bg>
       <p:bgPr>
@@ -3933,7 +4028,14 @@
         <p:cNvGrpSpPr/>
         <p:nvPr/>
       </p:nvGrpSpPr>
-      <p:grpSpPr/>
+      <p:grpSpPr>
+        <a:xfrm>
+          <a:off x="0" y="0"/>
+          <a:ext cx="0" cy="0"/>
+          <a:chOff x="0" y="0"/>
+          <a:chExt cx="0" cy="0"/>
+        </a:xfrm>
+      </p:grpSpPr>
       <p:sp>
         <p:nvSpPr>
           <p:cNvPr id="2" name="TextBox 1"/>
@@ -4094,7 +4196,7 @@
 </file>
 
 <file path=ppt/slides/slide5.xml><?xml version="1.0" encoding="utf-8"?>
-<p:sld xmlns:a="http://schemas.openxmlformats.org/drawingml/2006/main" xmlns:p="http://schemas.openxmlformats.org/presentationml/2006/main" xmlns:r="http://schemas.openxmlformats.org/officeDocument/2006/relationships">
+<p:sld xmlns:a="http://schemas.openxmlformats.org/drawingml/2006/main" xmlns:r="http://schemas.openxmlformats.org/officeDocument/2006/relationships" xmlns:p="http://schemas.openxmlformats.org/presentationml/2006/main">
   <p:cSld>
     <p:bg>
       <p:bgPr>
@@ -4110,7 +4212,14 @@
         <p:cNvGrpSpPr/>
         <p:nvPr/>
       </p:nvGrpSpPr>
-      <p:grpSpPr/>
+      <p:grpSpPr>
+        <a:xfrm>
+          <a:off x="0" y="0"/>
+          <a:ext cx="0" cy="0"/>
+          <a:chOff x="0" y="0"/>
+          <a:chExt cx="0" cy="0"/>
+        </a:xfrm>
+      </p:grpSpPr>
       <p:sp>
         <p:nvSpPr>
           <p:cNvPr id="2" name="TextBox 1"/>
@@ -4271,7 +4380,7 @@
 </file>
 
 <file path=ppt/slides/slide6.xml><?xml version="1.0" encoding="utf-8"?>
-<p:sld xmlns:a="http://schemas.openxmlformats.org/drawingml/2006/main" xmlns:p="http://schemas.openxmlformats.org/presentationml/2006/main" xmlns:r="http://schemas.openxmlformats.org/officeDocument/2006/relationships">
+<p:sld xmlns:a="http://schemas.openxmlformats.org/drawingml/2006/main" xmlns:r="http://schemas.openxmlformats.org/officeDocument/2006/relationships" xmlns:p="http://schemas.openxmlformats.org/presentationml/2006/main">
   <p:cSld>
     <p:bg>
       <p:bgPr>
@@ -4287,7 +4396,14 @@
         <p:cNvGrpSpPr/>
         <p:nvPr/>
       </p:nvGrpSpPr>
-      <p:grpSpPr/>
+      <p:grpSpPr>
+        <a:xfrm>
+          <a:off x="0" y="0"/>
+          <a:ext cx="0" cy="0"/>
+          <a:chOff x="0" y="0"/>
+          <a:chExt cx="0" cy="0"/>
+        </a:xfrm>
+      </p:grpSpPr>
       <p:sp>
         <p:nvSpPr>
           <p:cNvPr id="2" name="TextBox 1"/>
@@ -4463,7 +4579,7 @@
 </file>
 
 <file path=ppt/slides/slide7.xml><?xml version="1.0" encoding="utf-8"?>
-<p:sld xmlns:a="http://schemas.openxmlformats.org/drawingml/2006/main" xmlns:p="http://schemas.openxmlformats.org/presentationml/2006/main" xmlns:r="http://schemas.openxmlformats.org/officeDocument/2006/relationships">
+<p:sld xmlns:a="http://schemas.openxmlformats.org/drawingml/2006/main" xmlns:r="http://schemas.openxmlformats.org/officeDocument/2006/relationships" xmlns:p="http://schemas.openxmlformats.org/presentationml/2006/main">
   <p:cSld>
     <p:bg>
       <p:bgPr>
@@ -4479,7 +4595,14 @@
         <p:cNvGrpSpPr/>
         <p:nvPr/>
       </p:nvGrpSpPr>
-      <p:grpSpPr/>
+      <p:grpSpPr>
+        <a:xfrm>
+          <a:off x="0" y="0"/>
+          <a:ext cx="0" cy="0"/>
+          <a:chOff x="0" y="0"/>
+          <a:chExt cx="0" cy="0"/>
+        </a:xfrm>
+      </p:grpSpPr>
       <p:sp>
         <p:nvSpPr>
           <p:cNvPr id="2" name="TextBox 1"/>
@@ -4625,7 +4748,7 @@
 </file>
 
 <file path=ppt/slides/slide8.xml><?xml version="1.0" encoding="utf-8"?>
-<p:sld xmlns:a="http://schemas.openxmlformats.org/drawingml/2006/main" xmlns:p="http://schemas.openxmlformats.org/presentationml/2006/main" xmlns:r="http://schemas.openxmlformats.org/officeDocument/2006/relationships">
+<p:sld xmlns:a="http://schemas.openxmlformats.org/drawingml/2006/main" xmlns:r="http://schemas.openxmlformats.org/officeDocument/2006/relationships" xmlns:p="http://schemas.openxmlformats.org/presentationml/2006/main">
   <p:cSld>
     <p:bg>
       <p:bgPr>
@@ -4641,7 +4764,14 @@
         <p:cNvGrpSpPr/>
         <p:nvPr/>
       </p:nvGrpSpPr>
-      <p:grpSpPr/>
+      <p:grpSpPr>
+        <a:xfrm>
+          <a:off x="0" y="0"/>
+          <a:ext cx="0" cy="0"/>
+          <a:chOff x="0" y="0"/>
+          <a:chExt cx="0" cy="0"/>
+        </a:xfrm>
+      </p:grpSpPr>
       <p:sp>
         <p:nvSpPr>
           <p:cNvPr id="2" name="TextBox 1"/>
@@ -4802,7 +4932,7 @@
 </file>
 
 <file path=ppt/slides/slide9.xml><?xml version="1.0" encoding="utf-8"?>
-<p:sld xmlns:a="http://schemas.openxmlformats.org/drawingml/2006/main" xmlns:p="http://schemas.openxmlformats.org/presentationml/2006/main" xmlns:r="http://schemas.openxmlformats.org/officeDocument/2006/relationships">
+<p:sld xmlns:a="http://schemas.openxmlformats.org/drawingml/2006/main" xmlns:r="http://schemas.openxmlformats.org/officeDocument/2006/relationships" xmlns:p="http://schemas.openxmlformats.org/presentationml/2006/main">
   <p:cSld>
     <p:bg>
       <p:bgPr>
@@ -4818,7 +4948,14 @@
         <p:cNvGrpSpPr/>
         <p:nvPr/>
       </p:nvGrpSpPr>
-      <p:grpSpPr/>
+      <p:grpSpPr>
+        <a:xfrm>
+          <a:off x="0" y="0"/>
+          <a:ext cx="0" cy="0"/>
+          <a:chOff x="0" y="0"/>
+          <a:chExt cx="0" cy="0"/>
+        </a:xfrm>
+      </p:grpSpPr>
       <p:sp>
         <p:nvSpPr>
           <p:cNvPr id="2" name="TextBox 1"/>

</xml_diff>

<commit_message>
Submission: demo video link wired (README + slide 10), deck regenerated
</commit_message>
<xml_diff>
--- a/SWARN-CONTROL.AI.pptx
+++ b/SWARN-CONTROL.AI.pptx
@@ -5,18 +5,18 @@
     <p:sldMasterId id="2147483648" r:id="rId1"/>
   </p:sldMasterIdLst>
   <p:sldIdLst>
-    <p:sldId id="256" r:id="rId2"/>
-    <p:sldId id="257" r:id="rId3"/>
-    <p:sldId id="258" r:id="rId4"/>
-    <p:sldId id="259" r:id="rId5"/>
-    <p:sldId id="260" r:id="rId6"/>
-    <p:sldId id="261" r:id="rId7"/>
-    <p:sldId id="262" r:id="rId8"/>
-    <p:sldId id="263" r:id="rId9"/>
-    <p:sldId id="264" r:id="rId10"/>
-    <p:sldId id="265" r:id="rId11"/>
+    <p:sldId id="256" r:id="rId7"/>
+    <p:sldId id="257" r:id="rId8"/>
+    <p:sldId id="258" r:id="rId9"/>
+    <p:sldId id="259" r:id="rId10"/>
+    <p:sldId id="260" r:id="rId11"/>
+    <p:sldId id="261" r:id="rId12"/>
+    <p:sldId id="262" r:id="rId13"/>
+    <p:sldId id="263" r:id="rId14"/>
+    <p:sldId id="264" r:id="rId15"/>
+    <p:sldId id="265" r:id="rId16"/>
   </p:sldIdLst>
-  <p:sldSz cx="12188825" cy="6858000"/>
+  <p:sldSz cx="12188952" cy="6858000" type="screen4x3"/>
   <p:notesSz cx="6858000" cy="9144000"/>
   <p:defaultTextStyle>
     <a:defPPr>
@@ -113,22 +113,6 @@
       </a:defRPr>
     </a:lvl9pPr>
   </p:defaultTextStyle>
-  <p:extLst>
-    <p:ext uri="{EFAFB233-063F-42B5-8137-9DF3F51BA10A}">
-      <p15:sldGuideLst xmlns:p15="http://schemas.microsoft.com/office/powerpoint/2012/main">
-        <p15:guide id="1" orient="horz" pos="2160">
-          <p15:clr>
-            <a:srgbClr val="A4A3A4"/>
-          </p15:clr>
-        </p15:guide>
-        <p15:guide id="2" pos="2880">
-          <p15:clr>
-            <a:srgbClr val="A4A3A4"/>
-          </p15:clr>
-        </p15:guide>
-      </p15:sldGuideLst>
-    </p:ext>
-  </p:extLst>
 </p:presentation>
 </file>
 
@@ -170,9 +154,10 @@
           <a:lstStyle/>
           <a:p>
             <a:r>
-              <a:rPr lang="en-US"/>
+              <a:rPr lang="en-US" smtClean="0"/>
               <a:t>Click to edit Master title style</a:t>
             </a:r>
+            <a:endParaRPr lang="en-US"/>
           </a:p>
         </p:txBody>
       </p:sp>
@@ -288,9 +273,10 @@
           </a:lstStyle>
           <a:p>
             <a:r>
-              <a:rPr lang="en-US"/>
+              <a:rPr lang="en-US" smtClean="0"/>
               <a:t>Click to edit Master subtitle style</a:t>
             </a:r>
+            <a:endParaRPr lang="en-US"/>
           </a:p>
         </p:txBody>
       </p:sp>
@@ -311,7 +297,7 @@
           <a:p>
             <a:fld id="{5BCAD085-E8A6-8845-BD4E-CB4CCA059FC4}" type="datetimeFigureOut">
               <a:rPr lang="en-US" smtClean="0"/>
-              <a:t>10/2/2026</a:t>
+              <a:t>1/27/13</a:t>
             </a:fld>
             <a:endParaRPr lang="en-US"/>
           </a:p>
@@ -405,9 +391,10 @@
           <a:lstStyle/>
           <a:p>
             <a:r>
-              <a:rPr lang="en-US"/>
+              <a:rPr lang="en-US" smtClean="0"/>
               <a:t>Click to edit Master title style</a:t>
             </a:r>
+            <a:endParaRPr lang="en-US"/>
           </a:p>
         </p:txBody>
       </p:sp>
@@ -428,37 +415,38 @@
           <a:p>
             <a:pPr lvl="0"/>
             <a:r>
-              <a:rPr lang="en-US"/>
+              <a:rPr lang="en-US" smtClean="0"/>
               <a:t>Click to edit Master text styles</a:t>
             </a:r>
           </a:p>
           <a:p>
             <a:pPr lvl="1"/>
             <a:r>
-              <a:rPr lang="en-US"/>
+              <a:rPr lang="en-US" smtClean="0"/>
               <a:t>Second level</a:t>
             </a:r>
           </a:p>
           <a:p>
             <a:pPr lvl="2"/>
             <a:r>
-              <a:rPr lang="en-US"/>
+              <a:rPr lang="en-US" smtClean="0"/>
               <a:t>Third level</a:t>
             </a:r>
           </a:p>
           <a:p>
             <a:pPr lvl="3"/>
             <a:r>
-              <a:rPr lang="en-US"/>
+              <a:rPr lang="en-US" smtClean="0"/>
               <a:t>Fourth level</a:t>
             </a:r>
           </a:p>
           <a:p>
             <a:pPr lvl="4"/>
             <a:r>
-              <a:rPr lang="en-US"/>
+              <a:rPr lang="en-US" smtClean="0"/>
               <a:t>Fifth level</a:t>
             </a:r>
+            <a:endParaRPr lang="en-US"/>
           </a:p>
         </p:txBody>
       </p:sp>
@@ -479,7 +467,7 @@
           <a:p>
             <a:fld id="{5BCAD085-E8A6-8845-BD4E-CB4CCA059FC4}" type="datetimeFigureOut">
               <a:rPr lang="en-US" smtClean="0"/>
-              <a:t>10/2/2026</a:t>
+              <a:t>1/27/13</a:t>
             </a:fld>
             <a:endParaRPr lang="en-US"/>
           </a:p>
@@ -578,9 +566,10 @@
           <a:lstStyle/>
           <a:p>
             <a:r>
-              <a:rPr lang="en-US"/>
+              <a:rPr lang="en-US" smtClean="0"/>
               <a:t>Click to edit Master title style</a:t>
             </a:r>
+            <a:endParaRPr lang="en-US"/>
           </a:p>
         </p:txBody>
       </p:sp>
@@ -606,37 +595,38 @@
           <a:p>
             <a:pPr lvl="0"/>
             <a:r>
-              <a:rPr lang="en-US"/>
+              <a:rPr lang="en-US" smtClean="0"/>
               <a:t>Click to edit Master text styles</a:t>
             </a:r>
           </a:p>
           <a:p>
             <a:pPr lvl="1"/>
             <a:r>
-              <a:rPr lang="en-US"/>
+              <a:rPr lang="en-US" smtClean="0"/>
               <a:t>Second level</a:t>
             </a:r>
           </a:p>
           <a:p>
             <a:pPr lvl="2"/>
             <a:r>
-              <a:rPr lang="en-US"/>
+              <a:rPr lang="en-US" smtClean="0"/>
               <a:t>Third level</a:t>
             </a:r>
           </a:p>
           <a:p>
             <a:pPr lvl="3"/>
             <a:r>
-              <a:rPr lang="en-US"/>
+              <a:rPr lang="en-US" smtClean="0"/>
               <a:t>Fourth level</a:t>
             </a:r>
           </a:p>
           <a:p>
             <a:pPr lvl="4"/>
             <a:r>
-              <a:rPr lang="en-US"/>
+              <a:rPr lang="en-US" smtClean="0"/>
               <a:t>Fifth level</a:t>
             </a:r>
+            <a:endParaRPr lang="en-US"/>
           </a:p>
         </p:txBody>
       </p:sp>
@@ -657,7 +647,7 @@
           <a:p>
             <a:fld id="{5BCAD085-E8A6-8845-BD4E-CB4CCA059FC4}" type="datetimeFigureOut">
               <a:rPr lang="en-US" smtClean="0"/>
-              <a:t>10/2/2026</a:t>
+              <a:t>1/27/13</a:t>
             </a:fld>
             <a:endParaRPr lang="en-US"/>
           </a:p>
@@ -751,9 +741,10 @@
           <a:lstStyle/>
           <a:p>
             <a:r>
-              <a:rPr lang="en-US"/>
+              <a:rPr lang="en-US" smtClean="0"/>
               <a:t>Click to edit Master title style</a:t>
             </a:r>
+            <a:endParaRPr lang="en-US"/>
           </a:p>
         </p:txBody>
       </p:sp>
@@ -774,37 +765,38 @@
           <a:p>
             <a:pPr lvl="0"/>
             <a:r>
-              <a:rPr lang="en-US"/>
+              <a:rPr lang="en-US" smtClean="0"/>
               <a:t>Click to edit Master text styles</a:t>
             </a:r>
           </a:p>
           <a:p>
             <a:pPr lvl="1"/>
             <a:r>
-              <a:rPr lang="en-US"/>
+              <a:rPr lang="en-US" smtClean="0"/>
               <a:t>Second level</a:t>
             </a:r>
           </a:p>
           <a:p>
             <a:pPr lvl="2"/>
             <a:r>
-              <a:rPr lang="en-US"/>
+              <a:rPr lang="en-US" smtClean="0"/>
               <a:t>Third level</a:t>
             </a:r>
           </a:p>
           <a:p>
             <a:pPr lvl="3"/>
             <a:r>
-              <a:rPr lang="en-US"/>
+              <a:rPr lang="en-US" smtClean="0"/>
               <a:t>Fourth level</a:t>
             </a:r>
           </a:p>
           <a:p>
             <a:pPr lvl="4"/>
             <a:r>
-              <a:rPr lang="en-US"/>
+              <a:rPr lang="en-US" smtClean="0"/>
               <a:t>Fifth level</a:t>
             </a:r>
+            <a:endParaRPr lang="en-US"/>
           </a:p>
         </p:txBody>
       </p:sp>
@@ -825,7 +817,7 @@
           <a:p>
             <a:fld id="{5BCAD085-E8A6-8845-BD4E-CB4CCA059FC4}" type="datetimeFigureOut">
               <a:rPr lang="en-US" smtClean="0"/>
-              <a:t>10/2/2026</a:t>
+              <a:t>1/27/13</a:t>
             </a:fld>
             <a:endParaRPr lang="en-US"/>
           </a:p>
@@ -928,9 +920,10 @@
           </a:lstStyle>
           <a:p>
             <a:r>
-              <a:rPr lang="en-US"/>
+              <a:rPr lang="en-US" smtClean="0"/>
               <a:t>Click to edit Master title style</a:t>
             </a:r>
+            <a:endParaRPr lang="en-US"/>
           </a:p>
         </p:txBody>
       </p:sp>
@@ -1047,7 +1040,7 @@
           <a:p>
             <a:pPr lvl="0"/>
             <a:r>
-              <a:rPr lang="en-US"/>
+              <a:rPr lang="en-US" smtClean="0"/>
               <a:t>Click to edit Master text styles</a:t>
             </a:r>
           </a:p>
@@ -1070,7 +1063,7 @@
           <a:p>
             <a:fld id="{5BCAD085-E8A6-8845-BD4E-CB4CCA059FC4}" type="datetimeFigureOut">
               <a:rPr lang="en-US" smtClean="0"/>
-              <a:t>10/2/2026</a:t>
+              <a:t>1/27/13</a:t>
             </a:fld>
             <a:endParaRPr lang="en-US"/>
           </a:p>
@@ -1164,9 +1157,10 @@
           <a:lstStyle/>
           <a:p>
             <a:r>
-              <a:rPr lang="en-US"/>
+              <a:rPr lang="en-US" smtClean="0"/>
               <a:t>Click to edit Master title style</a:t>
             </a:r>
+            <a:endParaRPr lang="en-US"/>
           </a:p>
         </p:txBody>
       </p:sp>
@@ -1220,37 +1214,38 @@
           <a:p>
             <a:pPr lvl="0"/>
             <a:r>
-              <a:rPr lang="en-US"/>
+              <a:rPr lang="en-US" smtClean="0"/>
               <a:t>Click to edit Master text styles</a:t>
             </a:r>
           </a:p>
           <a:p>
             <a:pPr lvl="1"/>
             <a:r>
-              <a:rPr lang="en-US"/>
+              <a:rPr lang="en-US" smtClean="0"/>
               <a:t>Second level</a:t>
             </a:r>
           </a:p>
           <a:p>
             <a:pPr lvl="2"/>
             <a:r>
-              <a:rPr lang="en-US"/>
+              <a:rPr lang="en-US" smtClean="0"/>
               <a:t>Third level</a:t>
             </a:r>
           </a:p>
           <a:p>
             <a:pPr lvl="3"/>
             <a:r>
-              <a:rPr lang="en-US"/>
+              <a:rPr lang="en-US" smtClean="0"/>
               <a:t>Fourth level</a:t>
             </a:r>
           </a:p>
           <a:p>
             <a:pPr lvl="4"/>
             <a:r>
-              <a:rPr lang="en-US"/>
+              <a:rPr lang="en-US" smtClean="0"/>
               <a:t>Fifth level</a:t>
             </a:r>
+            <a:endParaRPr lang="en-US"/>
           </a:p>
         </p:txBody>
       </p:sp>
@@ -1304,37 +1299,38 @@
           <a:p>
             <a:pPr lvl="0"/>
             <a:r>
-              <a:rPr lang="en-US"/>
+              <a:rPr lang="en-US" smtClean="0"/>
               <a:t>Click to edit Master text styles</a:t>
             </a:r>
           </a:p>
           <a:p>
             <a:pPr lvl="1"/>
             <a:r>
-              <a:rPr lang="en-US"/>
+              <a:rPr lang="en-US" smtClean="0"/>
               <a:t>Second level</a:t>
             </a:r>
           </a:p>
           <a:p>
             <a:pPr lvl="2"/>
             <a:r>
-              <a:rPr lang="en-US"/>
+              <a:rPr lang="en-US" smtClean="0"/>
               <a:t>Third level</a:t>
             </a:r>
           </a:p>
           <a:p>
             <a:pPr lvl="3"/>
             <a:r>
-              <a:rPr lang="en-US"/>
+              <a:rPr lang="en-US" smtClean="0"/>
               <a:t>Fourth level</a:t>
             </a:r>
           </a:p>
           <a:p>
             <a:pPr lvl="4"/>
             <a:r>
-              <a:rPr lang="en-US"/>
+              <a:rPr lang="en-US" smtClean="0"/>
               <a:t>Fifth level</a:t>
             </a:r>
+            <a:endParaRPr lang="en-US"/>
           </a:p>
         </p:txBody>
       </p:sp>
@@ -1355,7 +1351,7 @@
           <a:p>
             <a:fld id="{5BCAD085-E8A6-8845-BD4E-CB4CCA059FC4}" type="datetimeFigureOut">
               <a:rPr lang="en-US" smtClean="0"/>
-              <a:t>10/2/2026</a:t>
+              <a:t>1/27/13</a:t>
             </a:fld>
             <a:endParaRPr lang="en-US"/>
           </a:p>
@@ -1453,9 +1449,10 @@
           </a:lstStyle>
           <a:p>
             <a:r>
-              <a:rPr lang="en-US"/>
+              <a:rPr lang="en-US" smtClean="0"/>
               <a:t>Click to edit Master title style</a:t>
             </a:r>
+            <a:endParaRPr lang="en-US"/>
           </a:p>
         </p:txBody>
       </p:sp>
@@ -1518,7 +1515,7 @@
           <a:p>
             <a:pPr lvl="0"/>
             <a:r>
-              <a:rPr lang="en-US"/>
+              <a:rPr lang="en-US" smtClean="0"/>
               <a:t>Click to edit Master text styles</a:t>
             </a:r>
           </a:p>
@@ -1574,37 +1571,38 @@
           <a:p>
             <a:pPr lvl="0"/>
             <a:r>
-              <a:rPr lang="en-US"/>
+              <a:rPr lang="en-US" smtClean="0"/>
               <a:t>Click to edit Master text styles</a:t>
             </a:r>
           </a:p>
           <a:p>
             <a:pPr lvl="1"/>
             <a:r>
-              <a:rPr lang="en-US"/>
+              <a:rPr lang="en-US" smtClean="0"/>
               <a:t>Second level</a:t>
             </a:r>
           </a:p>
           <a:p>
             <a:pPr lvl="2"/>
             <a:r>
-              <a:rPr lang="en-US"/>
+              <a:rPr lang="en-US" smtClean="0"/>
               <a:t>Third level</a:t>
             </a:r>
           </a:p>
           <a:p>
             <a:pPr lvl="3"/>
             <a:r>
-              <a:rPr lang="en-US"/>
+              <a:rPr lang="en-US" smtClean="0"/>
               <a:t>Fourth level</a:t>
             </a:r>
           </a:p>
           <a:p>
             <a:pPr lvl="4"/>
             <a:r>
-              <a:rPr lang="en-US"/>
+              <a:rPr lang="en-US" smtClean="0"/>
               <a:t>Fifth level</a:t>
             </a:r>
+            <a:endParaRPr lang="en-US"/>
           </a:p>
         </p:txBody>
       </p:sp>
@@ -1667,7 +1665,7 @@
           <a:p>
             <a:pPr lvl="0"/>
             <a:r>
-              <a:rPr lang="en-US"/>
+              <a:rPr lang="en-US" smtClean="0"/>
               <a:t>Click to edit Master text styles</a:t>
             </a:r>
           </a:p>
@@ -1723,37 +1721,38 @@
           <a:p>
             <a:pPr lvl="0"/>
             <a:r>
-              <a:rPr lang="en-US"/>
+              <a:rPr lang="en-US" smtClean="0"/>
               <a:t>Click to edit Master text styles</a:t>
             </a:r>
           </a:p>
           <a:p>
             <a:pPr lvl="1"/>
             <a:r>
-              <a:rPr lang="en-US"/>
+              <a:rPr lang="en-US" smtClean="0"/>
               <a:t>Second level</a:t>
             </a:r>
           </a:p>
           <a:p>
             <a:pPr lvl="2"/>
             <a:r>
-              <a:rPr lang="en-US"/>
+              <a:rPr lang="en-US" smtClean="0"/>
               <a:t>Third level</a:t>
             </a:r>
           </a:p>
           <a:p>
             <a:pPr lvl="3"/>
             <a:r>
-              <a:rPr lang="en-US"/>
+              <a:rPr lang="en-US" smtClean="0"/>
               <a:t>Fourth level</a:t>
             </a:r>
           </a:p>
           <a:p>
             <a:pPr lvl="4"/>
             <a:r>
-              <a:rPr lang="en-US"/>
+              <a:rPr lang="en-US" smtClean="0"/>
               <a:t>Fifth level</a:t>
             </a:r>
+            <a:endParaRPr lang="en-US"/>
           </a:p>
         </p:txBody>
       </p:sp>
@@ -1774,7 +1773,7 @@
           <a:p>
             <a:fld id="{5BCAD085-E8A6-8845-BD4E-CB4CCA059FC4}" type="datetimeFigureOut">
               <a:rPr lang="en-US" smtClean="0"/>
-              <a:t>10/2/2026</a:t>
+              <a:t>1/27/13</a:t>
             </a:fld>
             <a:endParaRPr lang="en-US"/>
           </a:p>
@@ -1868,9 +1867,10 @@
           <a:lstStyle/>
           <a:p>
             <a:r>
-              <a:rPr lang="en-US"/>
+              <a:rPr lang="en-US" smtClean="0"/>
               <a:t>Click to edit Master title style</a:t>
             </a:r>
+            <a:endParaRPr lang="en-US"/>
           </a:p>
         </p:txBody>
       </p:sp>
@@ -1891,7 +1891,7 @@
           <a:p>
             <a:fld id="{5BCAD085-E8A6-8845-BD4E-CB4CCA059FC4}" type="datetimeFigureOut">
               <a:rPr lang="en-US" smtClean="0"/>
-              <a:t>10/2/2026</a:t>
+              <a:t>1/27/13</a:t>
             </a:fld>
             <a:endParaRPr lang="en-US"/>
           </a:p>
@@ -1986,7 +1986,7 @@
           <a:p>
             <a:fld id="{5BCAD085-E8A6-8845-BD4E-CB4CCA059FC4}" type="datetimeFigureOut">
               <a:rPr lang="en-US" smtClean="0"/>
-              <a:t>10/2/2026</a:t>
+              <a:t>1/27/13</a:t>
             </a:fld>
             <a:endParaRPr lang="en-US"/>
           </a:p>
@@ -2089,9 +2089,10 @@
           </a:lstStyle>
           <a:p>
             <a:r>
-              <a:rPr lang="en-US"/>
+              <a:rPr lang="en-US" smtClean="0"/>
               <a:t>Click to edit Master title style</a:t>
             </a:r>
+            <a:endParaRPr lang="en-US"/>
           </a:p>
         </p:txBody>
       </p:sp>
@@ -2145,37 +2146,38 @@
           <a:p>
             <a:pPr lvl="0"/>
             <a:r>
-              <a:rPr lang="en-US"/>
+              <a:rPr lang="en-US" smtClean="0"/>
               <a:t>Click to edit Master text styles</a:t>
             </a:r>
           </a:p>
           <a:p>
             <a:pPr lvl="1"/>
             <a:r>
-              <a:rPr lang="en-US"/>
+              <a:rPr lang="en-US" smtClean="0"/>
               <a:t>Second level</a:t>
             </a:r>
           </a:p>
           <a:p>
             <a:pPr lvl="2"/>
             <a:r>
-              <a:rPr lang="en-US"/>
+              <a:rPr lang="en-US" smtClean="0"/>
               <a:t>Third level</a:t>
             </a:r>
           </a:p>
           <a:p>
             <a:pPr lvl="3"/>
             <a:r>
-              <a:rPr lang="en-US"/>
+              <a:rPr lang="en-US" smtClean="0"/>
               <a:t>Fourth level</a:t>
             </a:r>
           </a:p>
           <a:p>
             <a:pPr lvl="4"/>
             <a:r>
-              <a:rPr lang="en-US"/>
+              <a:rPr lang="en-US" smtClean="0"/>
               <a:t>Fifth level</a:t>
             </a:r>
+            <a:endParaRPr lang="en-US"/>
           </a:p>
         </p:txBody>
       </p:sp>
@@ -2238,7 +2240,7 @@
           <a:p>
             <a:pPr lvl="0"/>
             <a:r>
-              <a:rPr lang="en-US"/>
+              <a:rPr lang="en-US" smtClean="0"/>
               <a:t>Click to edit Master text styles</a:t>
             </a:r>
           </a:p>
@@ -2261,7 +2263,7 @@
           <a:p>
             <a:fld id="{5BCAD085-E8A6-8845-BD4E-CB4CCA059FC4}" type="datetimeFigureOut">
               <a:rPr lang="en-US" smtClean="0"/>
-              <a:t>10/2/2026</a:t>
+              <a:t>1/27/13</a:t>
             </a:fld>
             <a:endParaRPr lang="en-US"/>
           </a:p>
@@ -2364,9 +2366,10 @@
           </a:lstStyle>
           <a:p>
             <a:r>
-              <a:rPr lang="en-US"/>
+              <a:rPr lang="en-US" smtClean="0"/>
               <a:t>Click to edit Master title style</a:t>
             </a:r>
+            <a:endParaRPr lang="en-US"/>
           </a:p>
         </p:txBody>
       </p:sp>
@@ -2490,7 +2493,7 @@
           <a:p>
             <a:pPr lvl="0"/>
             <a:r>
-              <a:rPr lang="en-US"/>
+              <a:rPr lang="en-US" smtClean="0"/>
               <a:t>Click to edit Master text styles</a:t>
             </a:r>
           </a:p>
@@ -2513,7 +2516,7 @@
           <a:p>
             <a:fld id="{5BCAD085-E8A6-8845-BD4E-CB4CCA059FC4}" type="datetimeFigureOut">
               <a:rPr lang="en-US" smtClean="0"/>
-              <a:t>10/2/2026</a:t>
+              <a:t>1/27/13</a:t>
             </a:fld>
             <a:endParaRPr lang="en-US"/>
           </a:p>
@@ -2622,9 +2625,10 @@
           <a:lstStyle/>
           <a:p>
             <a:r>
-              <a:rPr lang="en-US"/>
+              <a:rPr lang="en-US" smtClean="0"/>
               <a:t>Click to edit Master title style</a:t>
             </a:r>
+            <a:endParaRPr lang="en-US"/>
           </a:p>
         </p:txBody>
       </p:sp>
@@ -2655,37 +2659,38 @@
           <a:p>
             <a:pPr lvl="0"/>
             <a:r>
-              <a:rPr lang="en-US"/>
+              <a:rPr lang="en-US" smtClean="0"/>
               <a:t>Click to edit Master text styles</a:t>
             </a:r>
           </a:p>
           <a:p>
             <a:pPr lvl="1"/>
             <a:r>
-              <a:rPr lang="en-US"/>
+              <a:rPr lang="en-US" smtClean="0"/>
               <a:t>Second level</a:t>
             </a:r>
           </a:p>
           <a:p>
             <a:pPr lvl="2"/>
             <a:r>
-              <a:rPr lang="en-US"/>
+              <a:rPr lang="en-US" smtClean="0"/>
               <a:t>Third level</a:t>
             </a:r>
           </a:p>
           <a:p>
             <a:pPr lvl="3"/>
             <a:r>
-              <a:rPr lang="en-US"/>
+              <a:rPr lang="en-US" smtClean="0"/>
               <a:t>Fourth level</a:t>
             </a:r>
           </a:p>
           <a:p>
             <a:pPr lvl="4"/>
             <a:r>
-              <a:rPr lang="en-US"/>
+              <a:rPr lang="en-US" smtClean="0"/>
               <a:t>Fifth level</a:t>
             </a:r>
+            <a:endParaRPr lang="en-US"/>
           </a:p>
         </p:txBody>
       </p:sp>
@@ -2724,7 +2729,7 @@
           <a:p>
             <a:fld id="{5BCAD085-E8A6-8845-BD4E-CB4CCA059FC4}" type="datetimeFigureOut">
               <a:rPr lang="en-US" smtClean="0"/>
-              <a:t>10/2/2026</a:t>
+              <a:t>1/27/13</a:t>
             </a:fld>
             <a:endParaRPr lang="en-US"/>
           </a:p>
@@ -3083,7 +3088,7 @@
 </file>
 
 <file path=ppt/slides/slide1.xml><?xml version="1.0" encoding="utf-8"?>
-<p:sld xmlns:a="http://schemas.openxmlformats.org/drawingml/2006/main" xmlns:r="http://schemas.openxmlformats.org/officeDocument/2006/relationships" xmlns:p="http://schemas.openxmlformats.org/presentationml/2006/main">
+<p:sld xmlns:a="http://schemas.openxmlformats.org/drawingml/2006/main" xmlns:p="http://schemas.openxmlformats.org/presentationml/2006/main" xmlns:r="http://schemas.openxmlformats.org/officeDocument/2006/relationships">
   <p:cSld>
     <p:bg>
       <p:bgPr>
@@ -3099,14 +3104,7 @@
         <p:cNvGrpSpPr/>
         <p:nvPr/>
       </p:nvGrpSpPr>
-      <p:grpSpPr>
-        <a:xfrm>
-          <a:off x="0" y="0"/>
-          <a:ext cx="0" cy="0"/>
-          <a:chOff x="0" y="0"/>
-          <a:chExt cx="0" cy="0"/>
-        </a:xfrm>
-      </p:grpSpPr>
+      <p:grpSpPr/>
       <p:sp>
         <p:nvSpPr>
           <p:cNvPr id="2" name="TextBox 1"/>
@@ -3320,7 +3318,7 @@
 </file>
 
 <file path=ppt/slides/slide10.xml><?xml version="1.0" encoding="utf-8"?>
-<p:sld xmlns:a="http://schemas.openxmlformats.org/drawingml/2006/main" xmlns:r="http://schemas.openxmlformats.org/officeDocument/2006/relationships" xmlns:p="http://schemas.openxmlformats.org/presentationml/2006/main">
+<p:sld xmlns:a="http://schemas.openxmlformats.org/drawingml/2006/main" xmlns:p="http://schemas.openxmlformats.org/presentationml/2006/main" xmlns:r="http://schemas.openxmlformats.org/officeDocument/2006/relationships">
   <p:cSld>
     <p:bg>
       <p:bgPr>
@@ -3336,14 +3334,7 @@
         <p:cNvGrpSpPr/>
         <p:nvPr/>
       </p:nvGrpSpPr>
-      <p:grpSpPr>
-        <a:xfrm>
-          <a:off x="0" y="0"/>
-          <a:ext cx="0" cy="0"/>
-          <a:chOff x="0" y="0"/>
-          <a:chExt cx="0" cy="0"/>
-        </a:xfrm>
-      </p:grpSpPr>
+      <p:grpSpPr/>
       <p:sp>
         <p:nvSpPr>
           <p:cNvPr id="2" name="TextBox 1"/>
@@ -3421,7 +3412,7 @@
         <p:spPr>
           <a:xfrm>
             <a:off x="731520" y="2194560"/>
-            <a:ext cx="10698480" cy="2395528"/>
+            <a:ext cx="10698480" cy="3840480"/>
           </a:xfrm>
           <a:prstGeom prst="rect">
             <a:avLst/>
@@ -3440,7 +3431,7 @@
               </a:spcAft>
             </a:pPr>
             <a:r>
-              <a:rPr sz="1800" dirty="0">
+              <a:rPr sz="1800">
                 <a:solidFill>
                   <a:srgbClr val="F2ECE2"/>
                 </a:solidFill>
@@ -3455,7 +3446,7 @@
               </a:spcAft>
             </a:pPr>
             <a:r>
-              <a:rPr sz="1800" dirty="0">
+              <a:rPr sz="1800">
                 <a:solidFill>
                   <a:srgbClr val="F2ECE2"/>
                 </a:solidFill>
@@ -3470,34 +3461,13 @@
               </a:spcAft>
             </a:pPr>
             <a:r>
-              <a:rPr sz="1800" dirty="0">
+              <a:rPr sz="1800">
                 <a:solidFill>
                   <a:srgbClr val="22D3EE"/>
                 </a:solidFill>
               </a:rPr>
-              <a:t>▸  Live Demo: </a:t>
-            </a:r>
-            <a:r>
-              <a:rPr lang="en-IN" dirty="0">
-                <a:solidFill>
-                  <a:srgbClr val="22D3EE"/>
-                </a:solidFill>
-              </a:rPr>
-              <a:t>https://swarna-control-ai.vercel.app</a:t>
-            </a:r>
-            <a:r>
-              <a:rPr sz="1800" dirty="0">
-                <a:solidFill>
-                  <a:srgbClr val="22D3EE"/>
-                </a:solidFill>
-              </a:rPr>
-              <a:t>· </a:t>
-            </a:r>
-            <a:endParaRPr lang="en-US" sz="1800" dirty="0">
-              <a:solidFill>
-                <a:srgbClr val="22D3EE"/>
-              </a:solidFill>
-            </a:endParaRPr>
+              <a:t>▸  Live Demo: https://swarna-control-ai.vercel.app  ·  Backend: https://swarn-control-backend.onrender.com  ·  GitHub: github.com/Aryansneha1845/SWARNA-CONTROL.AI</a:t>
+            </a:r>
           </a:p>
           <a:p>
             <a:pPr>
@@ -3506,63 +3476,12 @@
               </a:spcAft>
             </a:pPr>
             <a:r>
-              <a:rPr sz="1800" dirty="0">
-                <a:solidFill>
-                  <a:srgbClr val="22D3EE"/>
-                </a:solidFill>
-              </a:rPr>
-              <a:t> Backend: </a:t>
-            </a:r>
-            <a:r>
-              <a:rPr lang="en-IN" dirty="0">
-                <a:solidFill>
-                  <a:srgbClr val="22D3EE"/>
-                </a:solidFill>
-              </a:rPr>
-              <a:t> https://swarn-control-backend.onrender.com</a:t>
-            </a:r>
-            <a:r>
-              <a:rPr sz="1800" dirty="0">
-                <a:solidFill>
-                  <a:srgbClr val="22D3EE"/>
-                </a:solidFill>
-              </a:rPr>
-              <a:t>· </a:t>
-            </a:r>
-            <a:endParaRPr lang="en-US" sz="1800" dirty="0">
-              <a:solidFill>
-                <a:srgbClr val="22D3EE"/>
-              </a:solidFill>
-            </a:endParaRPr>
-          </a:p>
-          <a:p>
-            <a:pPr>
-              <a:spcAft>
-                <a:spcPts val="1000"/>
-              </a:spcAft>
-            </a:pPr>
-            <a:r>
-              <a:rPr sz="1800" dirty="0">
-                <a:solidFill>
-                  <a:srgbClr val="22D3EE"/>
-                </a:solidFill>
-              </a:rPr>
-              <a:t> GitHub: github.com/Aryansneha1845/SWARNA-CONTROL.AI</a:t>
-            </a:r>
-          </a:p>
-          <a:p>
-            <a:pPr>
-              <a:spcAft>
-                <a:spcPts val="1000"/>
-              </a:spcAft>
-            </a:pPr>
-            <a:r>
-              <a:rPr sz="1800" dirty="0">
+              <a:rPr sz="1800">
                 <a:solidFill>
                   <a:srgbClr val="93A1B5"/>
                 </a:solidFill>
               </a:rPr>
-              <a:t>▸  Video (4-min, Praveen case) + this deck + working prototype = complete submission.</a:t>
+              <a:t>▸  Video (4-min, Praveen case): https://youtu.be/c0CnQBTWU3E (Unlisted) + this deck + working prototype = complete submission.</a:t>
             </a:r>
           </a:p>
         </p:txBody>
@@ -3591,12 +3510,12 @@
           <a:p>
             <a:pPr algn="l"/>
             <a:r>
-              <a:rPr sz="1300" b="0" dirty="0">
+              <a:rPr sz="1300" b="0">
                 <a:solidFill>
                   <a:srgbClr val="93A1B5"/>
                 </a:solidFill>
               </a:rPr>
-              <a:t>Fill the two URLs after DEPLOY (docs/DEPLOY.md), then export this deck to PDF for submission.</a:t>
+              <a:t>Links verified Oct 2026: live demo + video + backend health all green.</a:t>
             </a:r>
           </a:p>
         </p:txBody>
@@ -3610,7 +3529,7 @@
 </file>
 
 <file path=ppt/slides/slide2.xml><?xml version="1.0" encoding="utf-8"?>
-<p:sld xmlns:a="http://schemas.openxmlformats.org/drawingml/2006/main" xmlns:r="http://schemas.openxmlformats.org/officeDocument/2006/relationships" xmlns:p="http://schemas.openxmlformats.org/presentationml/2006/main">
+<p:sld xmlns:a="http://schemas.openxmlformats.org/drawingml/2006/main" xmlns:p="http://schemas.openxmlformats.org/presentationml/2006/main" xmlns:r="http://schemas.openxmlformats.org/officeDocument/2006/relationships">
   <p:cSld>
     <p:bg>
       <p:bgPr>
@@ -3626,14 +3545,7 @@
         <p:cNvGrpSpPr/>
         <p:nvPr/>
       </p:nvGrpSpPr>
-      <p:grpSpPr>
-        <a:xfrm>
-          <a:off x="0" y="0"/>
-          <a:ext cx="0" cy="0"/>
-          <a:chOff x="0" y="0"/>
-          <a:chExt cx="0" cy="0"/>
-        </a:xfrm>
-      </p:grpSpPr>
+      <p:grpSpPr/>
       <p:sp>
         <p:nvSpPr>
           <p:cNvPr id="2" name="TextBox 1"/>
@@ -3794,7 +3706,7 @@
 </file>
 
 <file path=ppt/slides/slide3.xml><?xml version="1.0" encoding="utf-8"?>
-<p:sld xmlns:a="http://schemas.openxmlformats.org/drawingml/2006/main" xmlns:r="http://schemas.openxmlformats.org/officeDocument/2006/relationships" xmlns:p="http://schemas.openxmlformats.org/presentationml/2006/main">
+<p:sld xmlns:a="http://schemas.openxmlformats.org/drawingml/2006/main" xmlns:p="http://schemas.openxmlformats.org/presentationml/2006/main" xmlns:r="http://schemas.openxmlformats.org/officeDocument/2006/relationships">
   <p:cSld>
     <p:bg>
       <p:bgPr>
@@ -3810,14 +3722,7 @@
         <p:cNvGrpSpPr/>
         <p:nvPr/>
       </p:nvGrpSpPr>
-      <p:grpSpPr>
-        <a:xfrm>
-          <a:off x="0" y="0"/>
-          <a:ext cx="0" cy="0"/>
-          <a:chOff x="0" y="0"/>
-          <a:chExt cx="0" cy="0"/>
-        </a:xfrm>
-      </p:grpSpPr>
+      <p:grpSpPr/>
       <p:sp>
         <p:nvSpPr>
           <p:cNvPr id="2" name="TextBox 1"/>
@@ -4012,7 +3917,7 @@
 </file>
 
 <file path=ppt/slides/slide4.xml><?xml version="1.0" encoding="utf-8"?>
-<p:sld xmlns:a="http://schemas.openxmlformats.org/drawingml/2006/main" xmlns:r="http://schemas.openxmlformats.org/officeDocument/2006/relationships" xmlns:p="http://schemas.openxmlformats.org/presentationml/2006/main">
+<p:sld xmlns:a="http://schemas.openxmlformats.org/drawingml/2006/main" xmlns:p="http://schemas.openxmlformats.org/presentationml/2006/main" xmlns:r="http://schemas.openxmlformats.org/officeDocument/2006/relationships">
   <p:cSld>
     <p:bg>
       <p:bgPr>
@@ -4028,14 +3933,7 @@
         <p:cNvGrpSpPr/>
         <p:nvPr/>
       </p:nvGrpSpPr>
-      <p:grpSpPr>
-        <a:xfrm>
-          <a:off x="0" y="0"/>
-          <a:ext cx="0" cy="0"/>
-          <a:chOff x="0" y="0"/>
-          <a:chExt cx="0" cy="0"/>
-        </a:xfrm>
-      </p:grpSpPr>
+      <p:grpSpPr/>
       <p:sp>
         <p:nvSpPr>
           <p:cNvPr id="2" name="TextBox 1"/>
@@ -4196,7 +4094,7 @@
 </file>
 
 <file path=ppt/slides/slide5.xml><?xml version="1.0" encoding="utf-8"?>
-<p:sld xmlns:a="http://schemas.openxmlformats.org/drawingml/2006/main" xmlns:r="http://schemas.openxmlformats.org/officeDocument/2006/relationships" xmlns:p="http://schemas.openxmlformats.org/presentationml/2006/main">
+<p:sld xmlns:a="http://schemas.openxmlformats.org/drawingml/2006/main" xmlns:p="http://schemas.openxmlformats.org/presentationml/2006/main" xmlns:r="http://schemas.openxmlformats.org/officeDocument/2006/relationships">
   <p:cSld>
     <p:bg>
       <p:bgPr>
@@ -4212,14 +4110,7 @@
         <p:cNvGrpSpPr/>
         <p:nvPr/>
       </p:nvGrpSpPr>
-      <p:grpSpPr>
-        <a:xfrm>
-          <a:off x="0" y="0"/>
-          <a:ext cx="0" cy="0"/>
-          <a:chOff x="0" y="0"/>
-          <a:chExt cx="0" cy="0"/>
-        </a:xfrm>
-      </p:grpSpPr>
+      <p:grpSpPr/>
       <p:sp>
         <p:nvSpPr>
           <p:cNvPr id="2" name="TextBox 1"/>
@@ -4380,7 +4271,7 @@
 </file>
 
 <file path=ppt/slides/slide6.xml><?xml version="1.0" encoding="utf-8"?>
-<p:sld xmlns:a="http://schemas.openxmlformats.org/drawingml/2006/main" xmlns:r="http://schemas.openxmlformats.org/officeDocument/2006/relationships" xmlns:p="http://schemas.openxmlformats.org/presentationml/2006/main">
+<p:sld xmlns:a="http://schemas.openxmlformats.org/drawingml/2006/main" xmlns:p="http://schemas.openxmlformats.org/presentationml/2006/main" xmlns:r="http://schemas.openxmlformats.org/officeDocument/2006/relationships">
   <p:cSld>
     <p:bg>
       <p:bgPr>
@@ -4396,14 +4287,7 @@
         <p:cNvGrpSpPr/>
         <p:nvPr/>
       </p:nvGrpSpPr>
-      <p:grpSpPr>
-        <a:xfrm>
-          <a:off x="0" y="0"/>
-          <a:ext cx="0" cy="0"/>
-          <a:chOff x="0" y="0"/>
-          <a:chExt cx="0" cy="0"/>
-        </a:xfrm>
-      </p:grpSpPr>
+      <p:grpSpPr/>
       <p:sp>
         <p:nvSpPr>
           <p:cNvPr id="2" name="TextBox 1"/>
@@ -4579,7 +4463,7 @@
 </file>
 
 <file path=ppt/slides/slide7.xml><?xml version="1.0" encoding="utf-8"?>
-<p:sld xmlns:a="http://schemas.openxmlformats.org/drawingml/2006/main" xmlns:r="http://schemas.openxmlformats.org/officeDocument/2006/relationships" xmlns:p="http://schemas.openxmlformats.org/presentationml/2006/main">
+<p:sld xmlns:a="http://schemas.openxmlformats.org/drawingml/2006/main" xmlns:p="http://schemas.openxmlformats.org/presentationml/2006/main" xmlns:r="http://schemas.openxmlformats.org/officeDocument/2006/relationships">
   <p:cSld>
     <p:bg>
       <p:bgPr>
@@ -4595,14 +4479,7 @@
         <p:cNvGrpSpPr/>
         <p:nvPr/>
       </p:nvGrpSpPr>
-      <p:grpSpPr>
-        <a:xfrm>
-          <a:off x="0" y="0"/>
-          <a:ext cx="0" cy="0"/>
-          <a:chOff x="0" y="0"/>
-          <a:chExt cx="0" cy="0"/>
-        </a:xfrm>
-      </p:grpSpPr>
+      <p:grpSpPr/>
       <p:sp>
         <p:nvSpPr>
           <p:cNvPr id="2" name="TextBox 1"/>
@@ -4748,7 +4625,7 @@
 </file>
 
 <file path=ppt/slides/slide8.xml><?xml version="1.0" encoding="utf-8"?>
-<p:sld xmlns:a="http://schemas.openxmlformats.org/drawingml/2006/main" xmlns:r="http://schemas.openxmlformats.org/officeDocument/2006/relationships" xmlns:p="http://schemas.openxmlformats.org/presentationml/2006/main">
+<p:sld xmlns:a="http://schemas.openxmlformats.org/drawingml/2006/main" xmlns:p="http://schemas.openxmlformats.org/presentationml/2006/main" xmlns:r="http://schemas.openxmlformats.org/officeDocument/2006/relationships">
   <p:cSld>
     <p:bg>
       <p:bgPr>
@@ -4764,14 +4641,7 @@
         <p:cNvGrpSpPr/>
         <p:nvPr/>
       </p:nvGrpSpPr>
-      <p:grpSpPr>
-        <a:xfrm>
-          <a:off x="0" y="0"/>
-          <a:ext cx="0" cy="0"/>
-          <a:chOff x="0" y="0"/>
-          <a:chExt cx="0" cy="0"/>
-        </a:xfrm>
-      </p:grpSpPr>
+      <p:grpSpPr/>
       <p:sp>
         <p:nvSpPr>
           <p:cNvPr id="2" name="TextBox 1"/>
@@ -4932,7 +4802,7 @@
 </file>
 
 <file path=ppt/slides/slide9.xml><?xml version="1.0" encoding="utf-8"?>
-<p:sld xmlns:a="http://schemas.openxmlformats.org/drawingml/2006/main" xmlns:r="http://schemas.openxmlformats.org/officeDocument/2006/relationships" xmlns:p="http://schemas.openxmlformats.org/presentationml/2006/main">
+<p:sld xmlns:a="http://schemas.openxmlformats.org/drawingml/2006/main" xmlns:p="http://schemas.openxmlformats.org/presentationml/2006/main" xmlns:r="http://schemas.openxmlformats.org/officeDocument/2006/relationships">
   <p:cSld>
     <p:bg>
       <p:bgPr>
@@ -4948,14 +4818,7 @@
         <p:cNvGrpSpPr/>
         <p:nvPr/>
       </p:nvGrpSpPr>
-      <p:grpSpPr>
-        <a:xfrm>
-          <a:off x="0" y="0"/>
-          <a:ext cx="0" cy="0"/>
-          <a:chOff x="0" y="0"/>
-          <a:chExt cx="0" cy="0"/>
-        </a:xfrm>
-      </p:grpSpPr>
+      <p:grpSpPr/>
       <p:sp>
         <p:nvSpPr>
           <p:cNvPr id="2" name="TextBox 1"/>

</xml_diff>